<commit_message>
Restore patient journey title with high-contrast showcase typography
</commit_message>
<xml_diff>
--- a/submission/PathwayAI_MVP_Demo_Milestone.pptx
+++ b/submission/PathwayAI_MVP_Demo_Milestone.pptx
@@ -4101,8 +4101,8 @@
         </p:nvSpPr>
         <p:spPr>
           <a:xfrm>
-            <a:off x="740664" y="1508760"/>
-            <a:ext cx="7498079" cy="1463040"/>
+            <a:off x="740664" y="1143000"/>
+            <a:ext cx="7635240" cy="2011680"/>
           </a:xfrm>
           <a:prstGeom prst="rect">
             <a:avLst/>
@@ -4126,7 +4126,7 @@
                 <a:spcPts val="0"/>
               </a:spcBef>
               <a:spcAft>
-                <a:spcPts val="1000"/>
+                <a:spcPts val="1400"/>
               </a:spcAft>
               <a:buClr>
                 <a:srgbClr val="FFFFFF"/>
@@ -4136,9 +4136,9 @@
               <a:buNone/>
             </a:pPr>
             <a:r>
-              <a:rPr sz="3600" b="1">
-                <a:solidFill>
-                  <a:srgbClr val="192F4B"/>
+              <a:rPr sz="4400" b="1">
+                <a:solidFill>
+                  <a:srgbClr val="FFFFFF"/>
                 </a:solidFill>
                 <a:latin typeface="Roboto"/>
               </a:rPr>
@@ -4156,18 +4156,31 @@
           </a:p>
           <a:p>
             <a:pPr>
+              <a:lnSpc>
+                <a:spcPct val="115000"/>
+              </a:lnSpc>
               <a:spcAft>
                 <a:spcPts val="0"/>
               </a:spcAft>
             </a:pPr>
             <a:r>
-              <a:rPr sz="2600" b="1">
-                <a:solidFill>
-                  <a:srgbClr val="192F4B"/>
+              <a:rPr sz="2800" i="1">
+                <a:solidFill>
+                  <a:srgbClr val="CADCFC"/>
                 </a:solidFill>
                 <a:latin typeface="Roboto"/>
               </a:rPr>
-              <a:t>From Patient Voices to Community Action</a:t>
+              <a:t>Making the Hidden Patient Journey</a:t>
+            </a:r>
+            <a:br/>
+            <a:r>
+              <a:rPr sz="2800" i="1">
+                <a:solidFill>
+                  <a:srgbClr val="CADCFC"/>
+                </a:solidFill>
+                <a:latin typeface="Roboto"/>
+              </a:rPr>
+              <a:t>Visible—and Actionable</a:t>
             </a:r>
           </a:p>
         </p:txBody>
@@ -4180,7 +4193,7 @@
         </p:nvSpPr>
         <p:spPr>
           <a:xfrm>
-            <a:off x="744377" y="1051560"/>
+            <a:off x="744377" y="594360"/>
             <a:ext cx="4572000" cy="411600"/>
           </a:xfrm>
           <a:prstGeom prst="rect">
@@ -4246,8 +4259,8 @@
         </p:nvSpPr>
         <p:spPr>
           <a:xfrm>
-            <a:off x="744368" y="3246120"/>
-            <a:ext cx="6071100" cy="731520"/>
+            <a:off x="740664" y="3474720"/>
+            <a:ext cx="7315200" cy="868680"/>
           </a:xfrm>
           <a:prstGeom prst="rect">
             <a:avLst/>
@@ -4271,7 +4284,7 @@
                 <a:spcPts val="0"/>
               </a:spcBef>
               <a:spcAft>
-                <a:spcPts val="0"/>
+                <a:spcPts val="700"/>
               </a:spcAft>
               <a:buClr>
                 <a:srgbClr val="CADCFC"/>
@@ -4281,16 +4294,13 @@
               <a:buNone/>
             </a:pPr>
             <a:r>
-              <a:rPr lang="en-US" sz="1800">
-                <a:solidFill>
-                  <a:srgbClr val="CADCFC"/>
-                </a:solidFill>
-                <a:latin typeface="Merriweather"/>
-                <a:ea typeface="Merriweather"/>
-                <a:cs typeface="Merriweather"/>
-                <a:sym typeface="Merriweather"/>
+              <a:rPr sz="2200" b="1">
+                <a:solidFill>
+                  <a:srgbClr val="FFFFFF"/>
+                </a:solidFill>
+                <a:latin typeface="Roboto"/>
               </a:rPr>
-              <a:t>Yuwei Zhang | Team GreenAcorn</a:t>
+              <a:t>Team GreenAcorn</a:t>
             </a:r>
             <a:endParaRPr sz="1500" b="0" i="0" u="none" strike="noStrike" cap="none">
               <a:solidFill>
@@ -4301,6 +4311,17 @@
               <a:cs typeface="Merriweather"/>
               <a:sym typeface="Merriweather"/>
             </a:endParaRPr>
+          </a:p>
+          <a:p>
+            <a:r>
+              <a:rPr sz="2000">
+                <a:solidFill>
+                  <a:srgbClr val="CADCFC"/>
+                </a:solidFill>
+                <a:latin typeface="Roboto"/>
+              </a:rPr>
+              <a:t>Presented by Yuwei Zhang</a:t>
+            </a:r>
           </a:p>
         </p:txBody>
       </p:sp>
@@ -4444,7 +4465,7 @@
         </p:nvSpPr>
         <p:spPr>
           <a:xfrm>
-            <a:off x="744367" y="3090672"/>
+            <a:off x="744367" y="3246120"/>
             <a:ext cx="2148775" cy="11975"/>
           </a:xfrm>
           <a:custGeom>

</xml_diff>